<commit_message>
feat: finalize 10-slide Uzbek CPU heating/cooling PPTX generator
- Dual-path generator: python-pptx primary, pure-stdlib OOXML fallback
- Exactly 10 slides, Times New Roman only, all font sizes >= 12pt
- 3 reja sections + Xulosa; dark cyber/thermodynamics theme
- Image download with themed Uzbek-labelled placeholder fallback
- Verbatim Uzbek content; U+02BB apostrophe preserved
- verify_presentation.py enforces slide count, font, size, verbatim anchors
- Generated taqdimot.pptx (19418 bytes, 10 slides) committed
</commit_message>
<xml_diff>
--- a/taqdimot.pptx
+++ b/taqdimot.pptx
@@ -192,7 +192,7 @@
                 <a:cs typeface="Times New Roman"/>
                 <a:ea typeface="Times New Roman"/>
               </a:rPr>
-              <a:t>Computer Processor</a:t>
+              <a:t>Rasm: Protsessor</a:t>
             </a:r>
           </a:p>
         </p:txBody>
@@ -494,7 +494,7 @@
                 <a:cs typeface="Times New Roman"/>
                 <a:ea typeface="Times New Roman"/>
               </a:rPr>
-              <a:t>Abstract IT</a:t>
+              <a:t>Rasm: Axborot texnologiyalari</a:t>
             </a:r>
           </a:p>
         </p:txBody>
@@ -737,7 +737,7 @@
                 <a:cs typeface="Times New Roman"/>
                 <a:ea typeface="Times New Roman"/>
               </a:rPr>
-              <a:t>PC Internals</a:t>
+              <a:t>Rasm: Kompyuter ichki tuzilishi</a:t>
             </a:r>
           </a:p>
         </p:txBody>
@@ -998,7 +998,7 @@
                 <a:cs typeface="Times New Roman"/>
                 <a:ea typeface="Times New Roman"/>
               </a:rPr>
-              <a:t>Transistors Microchip</a:t>
+              <a:t>Rasm: Tranzistorlar va mikrochip</a:t>
             </a:r>
           </a:p>
         </p:txBody>
@@ -1241,7 +1241,7 @@
                 <a:cs typeface="Times New Roman"/>
                 <a:ea typeface="Times New Roman"/>
               </a:rPr>
-              <a:t>Physics Energy</a:t>
+              <a:t>Rasm: Energiya va fizika</a:t>
             </a:r>
           </a:p>
         </p:txBody>
@@ -1484,7 +1484,7 @@
                 <a:cs typeface="Times New Roman"/>
                 <a:ea typeface="Times New Roman"/>
               </a:rPr>
-              <a:t>Thermal Paste</a:t>
+              <a:t>Rasm: Termopasta</a:t>
             </a:r>
           </a:p>
         </p:txBody>
@@ -1727,7 +1727,7 @@
                 <a:cs typeface="Times New Roman"/>
                 <a:ea typeface="Times New Roman"/>
               </a:rPr>
-              <a:t>Heatsink</a:t>
+              <a:t>Rasm: Radiator (Heatsink)</a:t>
             </a:r>
           </a:p>
         </p:txBody>
@@ -1970,7 +1970,7 @@
                 <a:cs typeface="Times New Roman"/>
                 <a:ea typeface="Times New Roman"/>
               </a:rPr>
-              <a:t>Computer Fan</a:t>
+              <a:t>Rasm: Kuler (ventilyator)</a:t>
             </a:r>
           </a:p>
         </p:txBody>
@@ -2213,7 +2213,7 @@
                 <a:cs typeface="Times New Roman"/>
                 <a:ea typeface="Times New Roman"/>
               </a:rPr>
-              <a:t>Liquid Cooling</a:t>
+              <a:t>Rasm: Suvli sovutish</a:t>
             </a:r>
           </a:p>
         </p:txBody>
@@ -2456,7 +2456,7 @@
                 <a:cs typeface="Times New Roman"/>
                 <a:ea typeface="Times New Roman"/>
               </a:rPr>
-              <a:t>Data Center</a:t>
+              <a:t>Rasm: Ma'lumotlar markazi</a:t>
             </a:r>
           </a:p>
         </p:txBody>

</xml_diff>